<commit_message>
Timeline tears: update TearA/TearB geometry to the user's revised example shapes
Re-extracted both freeforms from Tear Example.pptx: TearA now 29.2x61.9 at -11.0/-16.1 with new nodes; TearB now 27.7x57.8 (shorter) with new nodes, still rot 180.

Co-Authored-By: Claude Opus 4.8 (1M context) <noreply@anthropic.com>
</commit_message>
<xml_diff>
--- a/Test Materials/Tear Example.pptx
+++ b/Test Materials/Tear Example.pptx
@@ -270,7 +270,7 @@
           <a:p>
             <a:fld id="{C3F56BF1-0EBC-4F31-8449-029BA8EA21B7}" type="datetimeFigureOut">
               <a:rPr lang="en-US" smtClean="0"/>
-              <a:t>6/10/2026</a:t>
+              <a:t>6/11/2026</a:t>
             </a:fld>
             <a:endParaRPr lang="en-US"/>
           </a:p>
@@ -468,7 +468,7 @@
           <a:p>
             <a:fld id="{C3F56BF1-0EBC-4F31-8449-029BA8EA21B7}" type="datetimeFigureOut">
               <a:rPr lang="en-US" smtClean="0"/>
-              <a:t>6/10/2026</a:t>
+              <a:t>6/11/2026</a:t>
             </a:fld>
             <a:endParaRPr lang="en-US"/>
           </a:p>
@@ -676,7 +676,7 @@
           <a:p>
             <a:fld id="{C3F56BF1-0EBC-4F31-8449-029BA8EA21B7}" type="datetimeFigureOut">
               <a:rPr lang="en-US" smtClean="0"/>
-              <a:t>6/10/2026</a:t>
+              <a:t>6/11/2026</a:t>
             </a:fld>
             <a:endParaRPr lang="en-US"/>
           </a:p>
@@ -874,7 +874,7 @@
           <a:p>
             <a:fld id="{C3F56BF1-0EBC-4F31-8449-029BA8EA21B7}" type="datetimeFigureOut">
               <a:rPr lang="en-US" smtClean="0"/>
-              <a:t>6/10/2026</a:t>
+              <a:t>6/11/2026</a:t>
             </a:fld>
             <a:endParaRPr lang="en-US"/>
           </a:p>
@@ -1149,7 +1149,7 @@
           <a:p>
             <a:fld id="{C3F56BF1-0EBC-4F31-8449-029BA8EA21B7}" type="datetimeFigureOut">
               <a:rPr lang="en-US" smtClean="0"/>
-              <a:t>6/10/2026</a:t>
+              <a:t>6/11/2026</a:t>
             </a:fld>
             <a:endParaRPr lang="en-US"/>
           </a:p>
@@ -1414,7 +1414,7 @@
           <a:p>
             <a:fld id="{C3F56BF1-0EBC-4F31-8449-029BA8EA21B7}" type="datetimeFigureOut">
               <a:rPr lang="en-US" smtClean="0"/>
-              <a:t>6/10/2026</a:t>
+              <a:t>6/11/2026</a:t>
             </a:fld>
             <a:endParaRPr lang="en-US"/>
           </a:p>
@@ -1826,7 +1826,7 @@
           <a:p>
             <a:fld id="{C3F56BF1-0EBC-4F31-8449-029BA8EA21B7}" type="datetimeFigureOut">
               <a:rPr lang="en-US" smtClean="0"/>
-              <a:t>6/10/2026</a:t>
+              <a:t>6/11/2026</a:t>
             </a:fld>
             <a:endParaRPr lang="en-US"/>
           </a:p>
@@ -1967,7 +1967,7 @@
           <a:p>
             <a:fld id="{C3F56BF1-0EBC-4F31-8449-029BA8EA21B7}" type="datetimeFigureOut">
               <a:rPr lang="en-US" smtClean="0"/>
-              <a:t>6/10/2026</a:t>
+              <a:t>6/11/2026</a:t>
             </a:fld>
             <a:endParaRPr lang="en-US"/>
           </a:p>
@@ -2080,7 +2080,7 @@
           <a:p>
             <a:fld id="{C3F56BF1-0EBC-4F31-8449-029BA8EA21B7}" type="datetimeFigureOut">
               <a:rPr lang="en-US" smtClean="0"/>
-              <a:t>6/10/2026</a:t>
+              <a:t>6/11/2026</a:t>
             </a:fld>
             <a:endParaRPr lang="en-US"/>
           </a:p>
@@ -2391,7 +2391,7 @@
           <a:p>
             <a:fld id="{C3F56BF1-0EBC-4F31-8449-029BA8EA21B7}" type="datetimeFigureOut">
               <a:rPr lang="en-US" smtClean="0"/>
-              <a:t>6/10/2026</a:t>
+              <a:t>6/11/2026</a:t>
             </a:fld>
             <a:endParaRPr lang="en-US"/>
           </a:p>
@@ -2679,7 +2679,7 @@
           <a:p>
             <a:fld id="{C3F56BF1-0EBC-4F31-8449-029BA8EA21B7}" type="datetimeFigureOut">
               <a:rPr lang="en-US" smtClean="0"/>
-              <a:t>6/10/2026</a:t>
+              <a:t>6/11/2026</a:t>
             </a:fld>
             <a:endParaRPr lang="en-US"/>
           </a:p>
@@ -2920,7 +2920,7 @@
           <a:p>
             <a:fld id="{C3F56BF1-0EBC-4F31-8449-029BA8EA21B7}" type="datetimeFigureOut">
               <a:rPr lang="en-US" smtClean="0"/>
-              <a:t>6/10/2026</a:t>
+              <a:t>6/11/2026</a:t>
             </a:fld>
             <a:endParaRPr lang="en-US"/>
           </a:p>
@@ -3493,8 +3493,8 @@
         </p:nvSpPr>
         <p:spPr>
           <a:xfrm>
-            <a:off x="3129191" y="721518"/>
-            <a:ext cx="377755" cy="773907"/>
+            <a:off x="3136335" y="709611"/>
+            <a:ext cx="370611" cy="785814"/>
           </a:xfrm>
           <a:custGeom>
             <a:avLst/>
@@ -3625,6 +3625,102 @@
               <a:gd name="csY6" fmla="*/ 292725 h 521303"/>
               <a:gd name="csX7" fmla="*/ 194956 w 371192"/>
               <a:gd name="csY7" fmla="*/ 0 h 521303"/>
+              <a:gd name="csX0" fmla="*/ 194956 w 371192"/>
+              <a:gd name="csY0" fmla="*/ 0 h 521303"/>
+              <a:gd name="csX1" fmla="*/ 371192 w 371192"/>
+              <a:gd name="csY1" fmla="*/ 315181 h 521303"/>
+              <a:gd name="csX2" fmla="*/ 251641 w 371192"/>
+              <a:gd name="csY2" fmla="*/ 315181 h 521303"/>
+              <a:gd name="csX3" fmla="*/ 371192 w 371192"/>
+              <a:gd name="csY3" fmla="*/ 521303 h 521303"/>
+              <a:gd name="csX4" fmla="*/ 0 w 371192"/>
+              <a:gd name="csY4" fmla="*/ 521303 h 521303"/>
+              <a:gd name="csX5" fmla="*/ 131250 w 371192"/>
+              <a:gd name="csY5" fmla="*/ 292725 h 521303"/>
+              <a:gd name="csX6" fmla="*/ 65517 w 371192"/>
+              <a:gd name="csY6" fmla="*/ 292725 h 521303"/>
+              <a:gd name="csX7" fmla="*/ 194956 w 371192"/>
+              <a:gd name="csY7" fmla="*/ 0 h 521303"/>
+              <a:gd name="csX0" fmla="*/ 194956 w 371192"/>
+              <a:gd name="csY0" fmla="*/ 0 h 521303"/>
+              <a:gd name="csX1" fmla="*/ 371192 w 371192"/>
+              <a:gd name="csY1" fmla="*/ 315181 h 521303"/>
+              <a:gd name="csX2" fmla="*/ 251641 w 371192"/>
+              <a:gd name="csY2" fmla="*/ 315181 h 521303"/>
+              <a:gd name="csX3" fmla="*/ 371192 w 371192"/>
+              <a:gd name="csY3" fmla="*/ 521303 h 521303"/>
+              <a:gd name="csX4" fmla="*/ 0 w 371192"/>
+              <a:gd name="csY4" fmla="*/ 521303 h 521303"/>
+              <a:gd name="csX5" fmla="*/ 131250 w 371192"/>
+              <a:gd name="csY5" fmla="*/ 292725 h 521303"/>
+              <a:gd name="csX6" fmla="*/ 65517 w 371192"/>
+              <a:gd name="csY6" fmla="*/ 292725 h 521303"/>
+              <a:gd name="csX7" fmla="*/ 194956 w 371192"/>
+              <a:gd name="csY7" fmla="*/ 0 h 521303"/>
+              <a:gd name="csX0" fmla="*/ 218355 w 371192"/>
+              <a:gd name="csY0" fmla="*/ 0 h 527719"/>
+              <a:gd name="csX1" fmla="*/ 371192 w 371192"/>
+              <a:gd name="csY1" fmla="*/ 321597 h 527719"/>
+              <a:gd name="csX2" fmla="*/ 251641 w 371192"/>
+              <a:gd name="csY2" fmla="*/ 321597 h 527719"/>
+              <a:gd name="csX3" fmla="*/ 371192 w 371192"/>
+              <a:gd name="csY3" fmla="*/ 527719 h 527719"/>
+              <a:gd name="csX4" fmla="*/ 0 w 371192"/>
+              <a:gd name="csY4" fmla="*/ 527719 h 527719"/>
+              <a:gd name="csX5" fmla="*/ 131250 w 371192"/>
+              <a:gd name="csY5" fmla="*/ 299141 h 527719"/>
+              <a:gd name="csX6" fmla="*/ 65517 w 371192"/>
+              <a:gd name="csY6" fmla="*/ 299141 h 527719"/>
+              <a:gd name="csX7" fmla="*/ 218355 w 371192"/>
+              <a:gd name="csY7" fmla="*/ 0 h 527719"/>
+              <a:gd name="csX0" fmla="*/ 208996 w 371192"/>
+              <a:gd name="csY0" fmla="*/ 0 h 524511"/>
+              <a:gd name="csX1" fmla="*/ 371192 w 371192"/>
+              <a:gd name="csY1" fmla="*/ 318389 h 524511"/>
+              <a:gd name="csX2" fmla="*/ 251641 w 371192"/>
+              <a:gd name="csY2" fmla="*/ 318389 h 524511"/>
+              <a:gd name="csX3" fmla="*/ 371192 w 371192"/>
+              <a:gd name="csY3" fmla="*/ 524511 h 524511"/>
+              <a:gd name="csX4" fmla="*/ 0 w 371192"/>
+              <a:gd name="csY4" fmla="*/ 524511 h 524511"/>
+              <a:gd name="csX5" fmla="*/ 131250 w 371192"/>
+              <a:gd name="csY5" fmla="*/ 295933 h 524511"/>
+              <a:gd name="csX6" fmla="*/ 65517 w 371192"/>
+              <a:gd name="csY6" fmla="*/ 295933 h 524511"/>
+              <a:gd name="csX7" fmla="*/ 208996 w 371192"/>
+              <a:gd name="csY7" fmla="*/ 0 h 524511"/>
+              <a:gd name="csX0" fmla="*/ 216015 w 371192"/>
+              <a:gd name="csY0" fmla="*/ 0 h 529323"/>
+              <a:gd name="csX1" fmla="*/ 371192 w 371192"/>
+              <a:gd name="csY1" fmla="*/ 323201 h 529323"/>
+              <a:gd name="csX2" fmla="*/ 251641 w 371192"/>
+              <a:gd name="csY2" fmla="*/ 323201 h 529323"/>
+              <a:gd name="csX3" fmla="*/ 371192 w 371192"/>
+              <a:gd name="csY3" fmla="*/ 529323 h 529323"/>
+              <a:gd name="csX4" fmla="*/ 0 w 371192"/>
+              <a:gd name="csY4" fmla="*/ 529323 h 529323"/>
+              <a:gd name="csX5" fmla="*/ 131250 w 371192"/>
+              <a:gd name="csY5" fmla="*/ 300745 h 529323"/>
+              <a:gd name="csX6" fmla="*/ 65517 w 371192"/>
+              <a:gd name="csY6" fmla="*/ 300745 h 529323"/>
+              <a:gd name="csX7" fmla="*/ 216015 w 371192"/>
+              <a:gd name="csY7" fmla="*/ 0 h 529323"/>
+              <a:gd name="csX0" fmla="*/ 208995 w 364172"/>
+              <a:gd name="csY0" fmla="*/ 0 h 529323"/>
+              <a:gd name="csX1" fmla="*/ 364172 w 364172"/>
+              <a:gd name="csY1" fmla="*/ 323201 h 529323"/>
+              <a:gd name="csX2" fmla="*/ 244621 w 364172"/>
+              <a:gd name="csY2" fmla="*/ 323201 h 529323"/>
+              <a:gd name="csX3" fmla="*/ 364172 w 364172"/>
+              <a:gd name="csY3" fmla="*/ 529323 h 529323"/>
+              <a:gd name="csX4" fmla="*/ 0 w 364172"/>
+              <a:gd name="csY4" fmla="*/ 527718 h 529323"/>
+              <a:gd name="csX5" fmla="*/ 124230 w 364172"/>
+              <a:gd name="csY5" fmla="*/ 300745 h 529323"/>
+              <a:gd name="csX6" fmla="*/ 58497 w 364172"/>
+              <a:gd name="csY6" fmla="*/ 300745 h 529323"/>
+              <a:gd name="csX7" fmla="*/ 208995 w 364172"/>
+              <a:gd name="csY7" fmla="*/ 0 h 529323"/>
             </a:gdLst>
             <a:ahLst/>
             <a:cxnLst>
@@ -3655,32 +3751,32 @@
             </a:cxnLst>
             <a:rect l="l" t="t" r="r" b="b"/>
             <a:pathLst>
-              <a:path w="371192" h="521303">
+              <a:path w="364172" h="529323">
                 <a:moveTo>
-                  <a:pt x="194956" y="0"/>
+                  <a:pt x="208995" y="0"/>
                 </a:moveTo>
                 <a:lnTo>
-                  <a:pt x="371192" y="315181"/>
+                  <a:pt x="364172" y="323201"/>
                 </a:lnTo>
                 <a:lnTo>
-                  <a:pt x="251641" y="315181"/>
+                  <a:pt x="244621" y="323201"/>
                 </a:lnTo>
                 <a:lnTo>
-                  <a:pt x="371192" y="521303"/>
+                  <a:pt x="364172" y="529323"/>
                 </a:lnTo>
                 <a:lnTo>
-                  <a:pt x="0" y="521303"/>
+                  <a:pt x="0" y="527718"/>
                 </a:lnTo>
                 <a:lnTo>
-                  <a:pt x="131250" y="292725"/>
+                  <a:pt x="124230" y="300745"/>
                 </a:lnTo>
                 <a:lnTo>
-                  <a:pt x="65517" y="292725"/>
+                  <a:pt x="58497" y="300745"/>
                 </a:lnTo>
                 <a:cubicBezTo>
-                  <a:pt x="127382" y="186061"/>
-                  <a:pt x="133091" y="106664"/>
-                  <a:pt x="194956" y="0"/>
+                  <a:pt x="108663" y="194081"/>
+                  <a:pt x="161169" y="100248"/>
+                  <a:pt x="208995" y="0"/>
                 </a:cubicBezTo>
                 <a:close/>
               </a:path>
@@ -3737,7 +3833,7 @@
         <p:spPr>
           <a:xfrm rot="10800000">
             <a:off x="3046254" y="800100"/>
-            <a:ext cx="351561" cy="764382"/>
+            <a:ext cx="351561" cy="733426"/>
           </a:xfrm>
           <a:custGeom>
             <a:avLst/>
@@ -3900,6 +3996,54 @@
               <a:gd name="csY6" fmla="*/ 303952 h 514887"/>
               <a:gd name="csX7" fmla="*/ 194956 w 345453"/>
               <a:gd name="csY7" fmla="*/ 0 h 514887"/>
+              <a:gd name="csX0" fmla="*/ 201976 w 345453"/>
+              <a:gd name="csY0" fmla="*/ 0 h 516491"/>
+              <a:gd name="csX1" fmla="*/ 345453 w 345453"/>
+              <a:gd name="csY1" fmla="*/ 310369 h 516491"/>
+              <a:gd name="csX2" fmla="*/ 225902 w 345453"/>
+              <a:gd name="csY2" fmla="*/ 310369 h 516491"/>
+              <a:gd name="csX3" fmla="*/ 345453 w 345453"/>
+              <a:gd name="csY3" fmla="*/ 516491 h 516491"/>
+              <a:gd name="csX4" fmla="*/ 0 w 345453"/>
+              <a:gd name="csY4" fmla="*/ 516491 h 516491"/>
+              <a:gd name="csX5" fmla="*/ 100832 w 345453"/>
+              <a:gd name="csY5" fmla="*/ 307161 h 516491"/>
+              <a:gd name="csX6" fmla="*/ 39777 w 345453"/>
+              <a:gd name="csY6" fmla="*/ 305556 h 516491"/>
+              <a:gd name="csX7" fmla="*/ 201976 w 345453"/>
+              <a:gd name="csY7" fmla="*/ 0 h 516491"/>
+              <a:gd name="csX0" fmla="*/ 201976 w 345453"/>
+              <a:gd name="csY0" fmla="*/ 0 h 516491"/>
+              <a:gd name="csX1" fmla="*/ 345453 w 345453"/>
+              <a:gd name="csY1" fmla="*/ 310369 h 516491"/>
+              <a:gd name="csX2" fmla="*/ 225902 w 345453"/>
+              <a:gd name="csY2" fmla="*/ 310369 h 516491"/>
+              <a:gd name="csX3" fmla="*/ 345453 w 345453"/>
+              <a:gd name="csY3" fmla="*/ 516491 h 516491"/>
+              <a:gd name="csX4" fmla="*/ 0 w 345453"/>
+              <a:gd name="csY4" fmla="*/ 516491 h 516491"/>
+              <a:gd name="csX5" fmla="*/ 100832 w 345453"/>
+              <a:gd name="csY5" fmla="*/ 307161 h 516491"/>
+              <a:gd name="csX6" fmla="*/ 32757 w 345453"/>
+              <a:gd name="csY6" fmla="*/ 307160 h 516491"/>
+              <a:gd name="csX7" fmla="*/ 201976 w 345453"/>
+              <a:gd name="csY7" fmla="*/ 0 h 516491"/>
+              <a:gd name="csX0" fmla="*/ 194957 w 345453"/>
+              <a:gd name="csY0" fmla="*/ 0 h 494035"/>
+              <a:gd name="csX1" fmla="*/ 345453 w 345453"/>
+              <a:gd name="csY1" fmla="*/ 287913 h 494035"/>
+              <a:gd name="csX2" fmla="*/ 225902 w 345453"/>
+              <a:gd name="csY2" fmla="*/ 287913 h 494035"/>
+              <a:gd name="csX3" fmla="*/ 345453 w 345453"/>
+              <a:gd name="csY3" fmla="*/ 494035 h 494035"/>
+              <a:gd name="csX4" fmla="*/ 0 w 345453"/>
+              <a:gd name="csY4" fmla="*/ 494035 h 494035"/>
+              <a:gd name="csX5" fmla="*/ 100832 w 345453"/>
+              <a:gd name="csY5" fmla="*/ 284705 h 494035"/>
+              <a:gd name="csX6" fmla="*/ 32757 w 345453"/>
+              <a:gd name="csY6" fmla="*/ 284704 h 494035"/>
+              <a:gd name="csX7" fmla="*/ 194957 w 345453"/>
+              <a:gd name="csY7" fmla="*/ 0 h 494035"/>
             </a:gdLst>
             <a:ahLst/>
             <a:cxnLst>
@@ -3930,32 +4074,32 @@
             </a:cxnLst>
             <a:rect l="l" t="t" r="r" b="b"/>
             <a:pathLst>
-              <a:path w="345453" h="514887">
+              <a:path w="345453" h="494035">
                 <a:moveTo>
-                  <a:pt x="194956" y="0"/>
+                  <a:pt x="194957" y="0"/>
                 </a:moveTo>
                 <a:lnTo>
-                  <a:pt x="345453" y="308765"/>
+                  <a:pt x="345453" y="287913"/>
                 </a:lnTo>
                 <a:lnTo>
-                  <a:pt x="225902" y="308765"/>
+                  <a:pt x="225902" y="287913"/>
                 </a:lnTo>
                 <a:lnTo>
-                  <a:pt x="345453" y="514887"/>
+                  <a:pt x="345453" y="494035"/>
                 </a:lnTo>
                 <a:lnTo>
-                  <a:pt x="0" y="514887"/>
+                  <a:pt x="0" y="494035"/>
                 </a:lnTo>
                 <a:lnTo>
-                  <a:pt x="100832" y="305557"/>
+                  <a:pt x="100832" y="284705"/>
                 </a:lnTo>
                 <a:lnTo>
-                  <a:pt x="39777" y="303952"/>
+                  <a:pt x="32757" y="284704"/>
                 </a:lnTo>
                 <a:cubicBezTo>
-                  <a:pt x="101642" y="197288"/>
-                  <a:pt x="133091" y="106664"/>
-                  <a:pt x="194956" y="0"/>
+                  <a:pt x="94622" y="178040"/>
+                  <a:pt x="133092" y="106664"/>
+                  <a:pt x="194957" y="0"/>
                 </a:cubicBezTo>
                 <a:close/>
               </a:path>

</xml_diff>

<commit_message>
Timeline tears: narrow TearB to the user's latest example (w 27.7->26.9, new nodes)
Co-Authored-By: Claude Opus 4.8 (1M context) <noreply@anthropic.com>
</commit_message>
<xml_diff>
--- a/Test Materials/Tear Example.pptx
+++ b/Test Materials/Tear Example.pptx
@@ -3832,8 +3832,8 @@
         </p:nvSpPr>
         <p:spPr>
           <a:xfrm rot="10800000">
-            <a:off x="3046254" y="800100"/>
-            <a:ext cx="351561" cy="733426"/>
+            <a:off x="3046255" y="800100"/>
+            <a:ext cx="342036" cy="733426"/>
           </a:xfrm>
           <a:custGeom>
             <a:avLst/>
@@ -4044,6 +4044,54 @@
               <a:gd name="csY6" fmla="*/ 284704 h 494035"/>
               <a:gd name="csX7" fmla="*/ 194957 w 345453"/>
               <a:gd name="csY7" fmla="*/ 0 h 494035"/>
+              <a:gd name="csX0" fmla="*/ 162200 w 312696"/>
+              <a:gd name="csY0" fmla="*/ 0 h 494035"/>
+              <a:gd name="csX1" fmla="*/ 312696 w 312696"/>
+              <a:gd name="csY1" fmla="*/ 287913 h 494035"/>
+              <a:gd name="csX2" fmla="*/ 193145 w 312696"/>
+              <a:gd name="csY2" fmla="*/ 287913 h 494035"/>
+              <a:gd name="csX3" fmla="*/ 312696 w 312696"/>
+              <a:gd name="csY3" fmla="*/ 494035 h 494035"/>
+              <a:gd name="csX4" fmla="*/ 4681 w 312696"/>
+              <a:gd name="csY4" fmla="*/ 492431 h 494035"/>
+              <a:gd name="csX5" fmla="*/ 68075 w 312696"/>
+              <a:gd name="csY5" fmla="*/ 284705 h 494035"/>
+              <a:gd name="csX6" fmla="*/ 0 w 312696"/>
+              <a:gd name="csY6" fmla="*/ 284704 h 494035"/>
+              <a:gd name="csX7" fmla="*/ 162200 w 312696"/>
+              <a:gd name="csY7" fmla="*/ 0 h 494035"/>
+              <a:gd name="csX0" fmla="*/ 185597 w 336093"/>
+              <a:gd name="csY0" fmla="*/ 0 h 494035"/>
+              <a:gd name="csX1" fmla="*/ 336093 w 336093"/>
+              <a:gd name="csY1" fmla="*/ 287913 h 494035"/>
+              <a:gd name="csX2" fmla="*/ 216542 w 336093"/>
+              <a:gd name="csY2" fmla="*/ 287913 h 494035"/>
+              <a:gd name="csX3" fmla="*/ 336093 w 336093"/>
+              <a:gd name="csY3" fmla="*/ 494035 h 494035"/>
+              <a:gd name="csX4" fmla="*/ 0 w 336093"/>
+              <a:gd name="csY4" fmla="*/ 489223 h 494035"/>
+              <a:gd name="csX5" fmla="*/ 91472 w 336093"/>
+              <a:gd name="csY5" fmla="*/ 284705 h 494035"/>
+              <a:gd name="csX6" fmla="*/ 23397 w 336093"/>
+              <a:gd name="csY6" fmla="*/ 284704 h 494035"/>
+              <a:gd name="csX7" fmla="*/ 185597 w 336093"/>
+              <a:gd name="csY7" fmla="*/ 0 h 494035"/>
+              <a:gd name="csX0" fmla="*/ 185597 w 336093"/>
+              <a:gd name="csY0" fmla="*/ 0 h 494035"/>
+              <a:gd name="csX1" fmla="*/ 336093 w 336093"/>
+              <a:gd name="csY1" fmla="*/ 287913 h 494035"/>
+              <a:gd name="csX2" fmla="*/ 216542 w 336093"/>
+              <a:gd name="csY2" fmla="*/ 287913 h 494035"/>
+              <a:gd name="csX3" fmla="*/ 336093 w 336093"/>
+              <a:gd name="csY3" fmla="*/ 494035 h 494035"/>
+              <a:gd name="csX4" fmla="*/ 0 w 336093"/>
+              <a:gd name="csY4" fmla="*/ 492430 h 494035"/>
+              <a:gd name="csX5" fmla="*/ 91472 w 336093"/>
+              <a:gd name="csY5" fmla="*/ 284705 h 494035"/>
+              <a:gd name="csX6" fmla="*/ 23397 w 336093"/>
+              <a:gd name="csY6" fmla="*/ 284704 h 494035"/>
+              <a:gd name="csX7" fmla="*/ 185597 w 336093"/>
+              <a:gd name="csY7" fmla="*/ 0 h 494035"/>
             </a:gdLst>
             <a:ahLst/>
             <a:cxnLst>
@@ -4074,32 +4122,32 @@
             </a:cxnLst>
             <a:rect l="l" t="t" r="r" b="b"/>
             <a:pathLst>
-              <a:path w="345453" h="494035">
+              <a:path w="336093" h="494035">
                 <a:moveTo>
-                  <a:pt x="194957" y="0"/>
+                  <a:pt x="185597" y="0"/>
                 </a:moveTo>
                 <a:lnTo>
-                  <a:pt x="345453" y="287913"/>
+                  <a:pt x="336093" y="287913"/>
                 </a:lnTo>
                 <a:lnTo>
-                  <a:pt x="225902" y="287913"/>
+                  <a:pt x="216542" y="287913"/>
                 </a:lnTo>
                 <a:lnTo>
-                  <a:pt x="345453" y="494035"/>
+                  <a:pt x="336093" y="494035"/>
                 </a:lnTo>
                 <a:lnTo>
-                  <a:pt x="0" y="494035"/>
+                  <a:pt x="0" y="492430"/>
                 </a:lnTo>
                 <a:lnTo>
-                  <a:pt x="100832" y="284705"/>
+                  <a:pt x="91472" y="284705"/>
                 </a:lnTo>
                 <a:lnTo>
-                  <a:pt x="32757" y="284704"/>
+                  <a:pt x="23397" y="284704"/>
                 </a:lnTo>
                 <a:cubicBezTo>
-                  <a:pt x="94622" y="178040"/>
-                  <a:pt x="133092" y="106664"/>
-                  <a:pt x="194957" y="0"/>
+                  <a:pt x="85262" y="178040"/>
+                  <a:pt x="123732" y="106664"/>
+                  <a:pt x="185597" y="0"/>
                 </a:cubicBezTo>
                 <a:close/>
               </a:path>

</xml_diff>